<commit_message>
Update presentation to 20261001 revision: Align 20-Yr Benefit with NPV .9M and Rent Priority
</commit_message>
<xml_diff>
--- a/assets/鉅鋼機械_光電方案簡報_MEDDIC顧問版.pptx
+++ b/assets/鉅鋼機械_光電方案簡報_MEDDIC顧問版.pptx
@@ -4624,7 +4624,7 @@
             </a:r>
             <a:br/>
             <a:r>
-              <a:t>高階主管與董事長查核決策簡報（2026/10 最新版）</a:t>
+              <a:t>高階主管與董事長查核決策簡報（2026/10/01 最新修訂版）</a:t>
             </a:r>
           </a:p>
         </p:txBody>
@@ -4694,7 +4694,7 @@
               </a:defRPr>
             </a:pPr>
             <a:r>
-              <a:t>呈閱：鉅鋼機械 董事長暨高階決策團隊 ｜ 規劃團隊：進金生能源服務 (6692) ｜ 顧問規範：森秀明 8 種無雜訊邏輯版型 × 麥肯錫/BCG/Accenture 視覺規範</a:t>
+              <a:t>呈閱：鉅鋼機械 董事長暨高階決策團隊 ｜ 規劃團隊：進金生能源服務 (6692) ｜ 顧問規範：森秀明 8 種無雜訊邏輯版型 × 麥肯錫/BCG/Accenture 視覺規範 ｜ 更新日期：2026/10/01</a:t>
             </a:r>
           </a:p>
         </p:txBody>
@@ -8777,7 +8777,7 @@
               </a:defRPr>
             </a:pPr>
             <a:r>
-              <a:t>Source: 20260930.pptx Slide 2, 3, 5, 6, 9, 12, 14 工程圖面與設備清冊</a:t>
+              <a:t>Source: 20261001.pptx Slide 2, 3, 5, 6, 9, 12, 14 工程圖面與設備清冊</a:t>
             </a:r>
           </a:p>
         </p:txBody>
@@ -8990,7 +8990,7 @@
               </a:defRPr>
             </a:pPr>
             <a:r>
-              <a:t>Source: 20260930.pptx Slide 4, 10 財務分析模型，折現率採用製造業標準 WACC = 5.0% 與內部 3.0% 對照</a:t>
+              <a:t>Source: 20261001.pptx Slide 4, 10 財務精算模型（方案二 20 年效益以 NPV $26,938,291 嚴格呈現）</a:t>
             </a:r>
           </a:p>
         </p:txBody>
@@ -9452,7 +9452,7 @@
               </a:defRPr>
             </a:pPr>
             <a:r>
-              <a:t>Source: 20260930.pptx Slide 10 Excel 精算表模型 (未稅)，每年發電衰減率以 0.8% 嚴格計算</a:t>
+              <a:t>Source: 20261001.pptx Slide 10 Excel 精算表模型 (未稅)，每年發電衰減率以 0.8% 嚴格計算</a:t>
             </a:r>
           </a:p>
         </p:txBody>
@@ -10627,7 +10627,7 @@
               </a:defRPr>
             </a:pPr>
             <a:r>
-              <a:t>依國泰建坤「首年工程價金 1.3 倍、逐年遞減 5%」公式，剖析各年回購門檻與隱形成本</a:t>
+              <a:t>依國泰建坤「首年工程價金 1.3 倍、逐年遞減 5%」公式，剖析「轉成發電自用」各年門檻與工程要件</a:t>
             </a:r>
           </a:p>
         </p:txBody>
@@ -10705,7 +10705,7 @@
               </a:defRPr>
             </a:pPr>
             <a:r>
-              <a:t>Source: 20260930.pptx Slide 8 回購試算表與進能服高壓併聯工程規範</a:t>
+              <a:t>Source: 20261001.pptx Slide 8 轉成發電自用回購試算表與進能服高壓併聯工程規範</a:t>
             </a:r>
           </a:p>
         </p:txBody>

</xml_diff>